<commit_message>
Add OCR (Tesseract + RapidOCR) for the scanned pressure forms and fluid analyses
Verify all 16 scanned PEMEX pressure surveys against the IFR transcription
(15 exact; the 9 Aug 1971 TEC-6 value was a repeat of 12 Aug and is corrected
from the form), recover the 1964 flowing RGA of 685 scf/bbl, and read the
Intertek 2018-19 stock-tank gravities (30.1-30.8 API) from the fluid scans.
Notes in docs/11_ocr.md; gaps G-31, G-37, G-51; deck and review updated.

Co-Authored-By: Claude Fable 5.1 <noreply@anthropic.com>
Claude-Session: https://claude.ai/code/session_018uoQyz51GKm4nrnU51DLDG
</commit_message>
<xml_diff>
--- a/docs/Tecolutla_TEC12_Handover.pptx
+++ b/docs/Tecolutla_TEC12_Handover.pptx
@@ -3932,7 +3932,7 @@
               <a:defRPr sz="1200"/>
             </a:pPr>
             <a:r>
-              <a:t>GOR: cumulative 565 scf/bbl 1966-92 (the source of IFR's 552); anomalies are allocation artefacts plus a local TEC-10 rise at low tubing pressure.</a:t>
+              <a:t>GOR: cumulative 565 scf/bbl 1966-92 (the source of IFR's 552); PEMEX measured 685 on TEC-6 in 1964. Stock-tank oil 30-31 API (Intertek 2018-19, OCR). No lab Rs or Pb exists.</a:t>
             </a:r>
           </a:p>
           <a:p>
@@ -4061,7 +4061,7 @@
               <a:defRPr sz="1200"/>
             </a:pPr>
             <a:r>
-              <a:t>21 surveys 1956-2018 restated at 2,300 mSS; four PEMEX scans read by eye against the transcription.</a:t>
+              <a:t>21 surveys 1956-2018 restated at 2,300 mSS; all 16 PEMEX scans OCR-verified (Tesseract + RapidOCR), one transcription error corrected.</a:t>
             </a:r>
           </a:p>
           <a:p>

</xml_diff>

<commit_message>
Add the Nov-2022 CNH measurement formats, KB and sales-report notes, and a deck slide for the second-pass sources
- Nov-2022 zip (VHP, VHPM, Balances) saved to data/raw/cnh_reports and
  transcribed: TEC-10DES 678 bbl net in 15 days, 30.9 API, 1.6 % S, gas
  flared; field restarted late Nov 2022 on TEC-10 alone.
- G-24: CRE semi-annual sales reports exist only as receipts; price annex
  absent. G-31: measured oil quality from the filings. G-46: masterlog KB
  5.13 m agrees with the CBL header against the 6.13 m in the header CSV.
- Deck gains slide 11 (second-pass sources, CMI figure); decisions slide
  renumbered 12. Review, README, manifest and CNH CSV updated.

Co-Authored-By: Claude Fable 5.1 <noreply@anthropic.com>
Claude-Session: https://claude.ai/code/session_018uoQyz51GKm4nrnU51DLDG
</commit_message>
<xml_diff>
--- a/docs/Tecolutla_TEC12_Handover.pptx
+++ b/docs/Tecolutla_TEC12_Handover.pptx
@@ -17,6 +17,7 @@
     <p:sldId id="265" r:id="rId16"/>
     <p:sldId id="266" r:id="rId17"/>
     <p:sldId id="267" r:id="rId18"/>
+    <p:sldId id="268" r:id="rId19"/>
   </p:sldIdLst>
   <p:sldSz cx="12191695" cy="6858000" type="screen4x3"/>
   <p:notesSz cx="6858000" cy="9144000"/>
@@ -3565,7 +3566,180 @@
               <a:defRPr sz="2400" b="1"/>
             </a:pPr>
             <a:r>
-              <a:t>11. Decisions and the gap register</a:t>
+              <a:t>11. New sources read in the second pass: CNH polygon, CMI fractures</a:t>
+            </a:r>
+          </a:p>
+        </p:txBody>
+      </p:sp>
+      <p:pic>
+        <p:nvPicPr>
+          <p:cNvPr id="3" name="Picture 2" descr="14_cmi_fractures.png"/>
+          <p:cNvPicPr>
+            <a:picLocks noChangeAspect="1"/>
+          </p:cNvPicPr>
+          <p:nvPr/>
+        </p:nvPicPr>
+        <p:blipFill>
+          <a:blip r:embed="rId2"/>
+          <a:stretch>
+            <a:fillRect/>
+          </a:stretch>
+        </p:blipFill>
+        <p:spPr>
+          <a:xfrm>
+            <a:off x="274320" y="914400"/>
+            <a:ext cx="6035040" cy="4023360"/>
+          </a:xfrm>
+          <a:prstGeom prst="rect">
+            <a:avLst/>
+          </a:prstGeom>
+        </p:spPr>
+      </p:pic>
+      <p:sp>
+        <p:nvSpPr>
+          <p:cNvPr id="4" name="TextBox 3"/>
+          <p:cNvSpPr txBox="1"/>
+          <p:nvPr/>
+        </p:nvSpPr>
+        <p:spPr>
+          <a:xfrm>
+            <a:off x="6492240" y="914400"/>
+            <a:ext cx="5394960" cy="5669280"/>
+          </a:xfrm>
+          <a:prstGeom prst="rect">
+            <a:avLst/>
+          </a:prstGeom>
+          <a:noFill/>
+        </p:spPr>
+        <p:txBody>
+          <a:bodyPr wrap="square">
+            <a:spAutoFit/>
+          </a:bodyPr>
+          <a:lstStyle/>
+          <a:p>
+            <a:pPr>
+              <a:spcAft>
+                <a:spcPts val="600"/>
+              </a:spcAft>
+              <a:defRPr sz="1200"/>
+            </a:pPr>
+            <a:r>
+              <a:t>Ten large Drive files read through the connector's text rendering (Work Program, GLJ detail, core report, mud logs, gauge data): docs/12.</a:t>
+            </a:r>
+          </a:p>
+          <a:p>
+            <a:pPr>
+              <a:spcAft>
+                <a:spcPts val="600"/>
+              </a:spcAft>
+              <a:defRPr sz="1200"/>
+            </a:pPr>
+            <a:r>
+              <a:t>CNH field polygon (2015 data room): 3.14 km2, all nine wells inside; IFR's 630 ac = 2.55 km2 is 81 % of it. An administrative outline, the upper bound of the OOIP range (G-43 closed).</a:t>
+            </a:r>
+          </a:p>
+          <a:p>
+            <a:pPr>
+              <a:spcAft>
+                <a:spcPts val="600"/>
+              </a:spcAft>
+              <a:defRPr sz="1200"/>
+            </a:pPr>
+            <a:r>
+              <a:t>CNH forecast tables filed for 2021 and 2022 carry the IFR 2020 TEC-12 curve (300 bbl/d first month), not 500 kbbl (G-22 closed).</a:t>
+            </a:r>
+          </a:p>
+          <a:p>
+            <a:pPr>
+              <a:spcAft>
+                <a:spcPts val="600"/>
+              </a:spcAft>
+              <a:defRPr sz="1200"/>
+            </a:pPr>
+            <a:r>
+              <a:t>CNH annual filings: 16.1 kbbl (2020, both wells, Apr-Jun shut in), 17.4 kbbl (2021, TEC-10 only, GOR 859 scf/bbl, 29.3 API); field shut in from Jul 2022, restarted late Nov 2022 on TEC-10.</a:t>
+            </a:r>
+          </a:p>
+          <a:p>
+            <a:pPr>
+              <a:spcAft>
+                <a:spcPts val="600"/>
+              </a:spcAft>
+              <a:defRPr sz="1200"/>
+            </a:pPr>
+            <a:r>
+              <a:t>TEC-10 core (only rock data): recrystallised grainstone, 2-8 % porosity, 0.01-0.5 mD at stress, 14-59 % PV residual oil; no electrical properties.</a:t>
+            </a:r>
+          </a:p>
+          <a:p>
+            <a:pPr>
+              <a:spcAft>
+                <a:spcPts val="600"/>
+              </a:spcAft>
+              <a:defRPr sz="1200"/>
+            </a:pPr>
+            <a:r>
+              <a:t>CMI (right): no open fracture in the TEC-12 window or the perforated 10 m; open fractures start below 2,320 mSS in the produced, water-bearing interval. TEC-10 is matrix flow (G-09 closed).</a:t>
+            </a:r>
+          </a:p>
+          <a:p>
+            <a:pPr>
+              <a:spcAft>
+                <a:spcPts val="600"/>
+              </a:spcAft>
+              <a:defRPr sz="1200"/>
+            </a:pPr>
+            <a:r>
+              <a:t>2025 reform: contract fiscal terms preserved per secondary sources; regulator now CNE; contract-to-assignment substitution clause to be checked by counsel (G-49).</a:t>
+            </a:r>
+          </a:p>
+        </p:txBody>
+      </p:sp>
+    </p:spTree>
+  </p:cSld>
+  <p:clrMapOvr>
+    <a:masterClrMapping/>
+  </p:clrMapOvr>
+</p:sld>
+</file>
+
+<file path=ppt/slides/slide13.xml><?xml version="1.0" encoding="utf-8"?>
+<p:sld xmlns:a="http://schemas.openxmlformats.org/drawingml/2006/main" xmlns:p="http://schemas.openxmlformats.org/presentationml/2006/main" xmlns:r="http://schemas.openxmlformats.org/officeDocument/2006/relationships">
+  <p:cSld>
+    <p:spTree>
+      <p:nvGrpSpPr>
+        <p:cNvPr id="1" name=""/>
+        <p:cNvGrpSpPr/>
+        <p:nvPr/>
+      </p:nvGrpSpPr>
+      <p:grpSpPr/>
+      <p:sp>
+        <p:nvSpPr>
+          <p:cNvPr id="2" name="TextBox 1"/>
+          <p:cNvSpPr txBox="1"/>
+          <p:nvPr/>
+        </p:nvSpPr>
+        <p:spPr>
+          <a:xfrm>
+            <a:off x="365760" y="182880"/>
+            <a:ext cx="11430000" cy="731520"/>
+          </a:xfrm>
+          <a:prstGeom prst="rect">
+            <a:avLst/>
+          </a:prstGeom>
+          <a:noFill/>
+        </p:spPr>
+        <p:txBody>
+          <a:bodyPr wrap="none">
+            <a:spAutoFit/>
+          </a:bodyPr>
+          <a:lstStyle/>
+          <a:p>
+            <a:pPr>
+              <a:defRPr sz="2400" b="1"/>
+            </a:pPr>
+            <a:r>
+              <a:t>12. Decisions and the gap register</a:t>
             </a:r>
           </a:p>
         </p:txBody>

</xml_diff>

<commit_message>
TEC-10 water-saturation sensitivity for the TEC-12 window (G-47 narrowed)
72-case Archie/Simandoux sensitivity anchored three ways (aquifer below LKO,
producing interval at Sw 0.55, book Rw) with m 1.8-2.2, two porosity bases
and a neutron-density clay correction. On the density porosity, which the
core plugs support, the window is water-saturated under every anchor while
the perforated interval sits at 0.6-1.0; the neutron-density crossover flips
sign at 2,311 mSS. docs/14_sw_sensitivity.md, figure 15, gap register,
review risk table and deck slide 11 updated.

Co-Authored-By: Claude Fable 5.1 <noreply@anthropic.com>
Claude-Session: https://claude.ai/code/session_018uoQyz51GKm4nrnU51DLDG
</commit_message>
<xml_diff>
--- a/docs/Tecolutla_TEC12_Handover.pptx
+++ b/docs/Tecolutla_TEC12_Handover.pptx
@@ -3680,6 +3680,17 @@
             </a:pPr>
             <a:r>
               <a:t>CMI (right): no open fracture in the TEC-12 window or the perforated 10 m; open fractures start below 2,320 mSS in the produced, water-bearing interval. TEC-10 is matrix flow (G-09 closed).</a:t>
+            </a:r>
+          </a:p>
+          <a:p>
+            <a:pPr>
+              <a:spcAft>
+                <a:spcPts val="600"/>
+              </a:spcAft>
+              <a:defRPr sz="1200"/>
+            </a:pPr>
+            <a:r>
+              <a:t>Sw sensitivity (72 cases, anchored to the aquifer and the producing interval): the window is water at TEC-10 on the core-supported density porosity, Sw &gt;= 1.1 vs 0.6-1.0 in the perforations; N-D crossover flips sign at 2,311 mSS. Base case on 2,311-2,332 mSS; the window is upside only if TEC-12 logs it cleaner (docs/14).</a:t>
             </a:r>
           </a:p>
           <a:p>

</xml_diff>

<commit_message>
G-46 closed: TEC-10 depths on the directional survey, KB 6.13 m
- Decision of the author, 16 Sep 2026: the directional-survey KB 6.13 m is the basis for every TEC-10 subsea depth. Log panel, saturation and CMI work already used it.
- src/pressure_db.py switches the 2018 TEC-10 build-up from the IHS report's 7.1 m KB to 6.13 m: gauge 2,315.97 mSS, datum pressure 24.14 MPa (was 24.15); 2018 range 24.14-24.16 unchanged.
- docs/05, docs/09, review v4, deck slide 9 and gap register updated; masterlog/CBL 5.13 m kept as a source discrepancy note. 13 of 53 gaps open.

Co-Authored-By: Claude Fable 5.1 <noreply@anthropic.com>
Claude-Session: https://claude.ai/code/session_018uoQyz51GKm4nrnU51DLDG
</commit_message>
<xml_diff>
--- a/docs/Tecolutla_TEC12_Handover.pptx
+++ b/docs/Tecolutla_TEC12_Handover.pptx
@@ -3828,7 +3828,7 @@
               <a:defRPr sz="1400"/>
             </a:pPr>
             <a:r>
-              <a:t>53 gaps logged in docs/gaps.md with status; 14 remain open. Kevin: the Aug-2025 re-saves (G-03), which well the 2023 model priced (G-17), the 2020 CNH filing gross-vs-net oil (G-53), a Drive API pull or manual download of the ten large binaries (G-52).</a:t>
+              <a:t>53 gaps logged in docs/gaps.md with status; 13 remain open. Kevin: the Aug-2025 re-saves (G-03), which well the 2023 model priced (G-17), the 2020 CNH filing gross-vs-net oil (G-53), a Drive API pull or manual download of the ten large binaries (G-52).</a:t>
             </a:r>
           </a:p>
         </p:txBody>
@@ -5078,7 +5078,7 @@
               <a:defRPr sz="1200"/>
             </a:pPr>
             <a:r>
-              <a:t>TEC-10 top perf is 2,314 mSS on the survey vs 2,311.5 in the summary sheet (G-46).</a:t>
+              <a:t>TEC-10 top perf is 2,314 mSS on the survey vs 2,311.5 in the summary sheet; all TEC-10 depths here are on the survey, KB 6.13 m (G-46 closed by decision).</a:t>
             </a:r>
           </a:p>
         </p:txBody>

</xml_diff>

<commit_message>
Economics on GLJ 1 Oct 2026 prices; PPI-indexed AFE; area fiscal charges in stand-alone only (G-45, G-60 closed)
Primary case: GLJ Oct 2026 WTI then-current, costs +2 %/yr, 0.81 x WTI. TEC-12
incremental NPV10 BTAX +0.47 MM (was +0.27 at flat WTI 70), stand-alone -0.45 MM.
AFE base USD 2.04 MM (x1.297). Docs 08/10, review v4, three decks and the briefing updated.

Co-Authored-By: Claude Opus 5.5 <noreply@anthropic.com>
Claude-Session: https://claude.ai/code/session_018uoQyz51GKm4nrnU51DLDG
</commit_message>
<xml_diff>
--- a/docs/Tecolutla_TEC12_Handover.pptx
+++ b/docs/Tecolutla_TEC12_Handover.pptx
@@ -3355,7 +3355,7 @@
               <a:defRPr sz="1200"/>
             </a:pPr>
             <a:r>
-              <a:t>Escalated to Sep 2026 (assumed x1.15 / 1.25 / 1.40; index blocked, G-45): USD 1.81 / 1.97 / 2.20 MM = CAD 2.52 / 2.74 / 3.06 MM at 1.3915.</a:t>
+              <a:t>Escalated to Sep 2026 on the US drilling PPI (309.4 -&gt; 401.3, x1.297; G-45 closed): base USD 2.04 MM = CAD 2.84 MM at 1.3915; range x1.15-1.40 = USD 1.81-2.20 MM.</a:t>
             </a:r>
           </a:p>
         </p:txBody>
@@ -3426,7 +3426,7 @@
         <p:spPr>
           <a:xfrm>
             <a:off x="274320" y="914400"/>
-            <a:ext cx="7498079" cy="3046095"/>
+            <a:ext cx="7498079" cy="3099206"/>
           </a:xfrm>
           <a:prstGeom prst="rect">
             <a:avLst/>
@@ -3462,51 +3462,51 @@
               <a:defRPr sz="1200"/>
             </a:pPr>
             <a:r>
-              <a:t>Fiscal and cost terms from the 2023 workbook; base profile; escalated base AFE; water cut following TEC-10; start Jan 2027; 100 % WI; no G&amp;A, no carry.</a:t>
-            </a:r>
-          </a:p>
-          <a:p>
-            <a:pPr>
-              <a:spcAft>
-                <a:spcPts val="600"/>
-              </a:spcAft>
-              <a:defRPr sz="1200"/>
-            </a:pPr>
-            <a:r>
-              <a:t>Realised price 0.81 x WTI from 37 PEMEX settlements (2020-22). Stand-alone NPV10 BTAX at WTI 60/70/80: base -0.92 / -0.46 / +0.02 MM; high -0.39 / +0.25 / +0.92; low never positive.</a:t>
-            </a:r>
-          </a:p>
-          <a:p>
-            <a:pPr>
-              <a:spcAft>
-                <a:spcPts val="600"/>
-              </a:spcAft>
-              <a:defRPr sz="1200"/>
-            </a:pPr>
-            <a:r>
-              <a:t>Incremental to a producing TEC-10 (battery and disposal already carried): base -0.34 / +0.27 / +0.89 MM, payout 32 months at WTI 70. The 2023 model's 0.90 factor added 0.4-0.5 MM to every case.</a:t>
-            </a:r>
-          </a:p>
-          <a:p>
-            <a:pPr>
-              <a:spcAft>
-                <a:spcPts val="600"/>
-              </a:spcAft>
-              <a:defRPr sz="1200"/>
-            </a:pPr>
-            <a:r>
-              <a:t>Royalty burden 42-44 % of revenue; fixed costs end the stand-alone base case at 61 months with 134 of 218 kbbl produced.</a:t>
-            </a:r>
-          </a:p>
-          <a:p>
-            <a:pPr>
-              <a:spcAft>
-                <a:spcPts val="600"/>
-              </a:spcAft>
-              <a:defRPr sz="1200"/>
-            </a:pPr>
-            <a:r>
-              <a:t>WTI ~USD 100 in mid-Sep 2026 on a supply disruption; long-term decks 70-80. 2025 fiscal reform not reviewed (G-49).</a:t>
+              <a:t>GLJ 1 Oct 2026 prices (WTI 81 / 75 / 73, then +2 %/yr), costs +2 %/yr; 2023 royalty, tax and opex terms; PPI-indexed AFE; area fiscal charges (USD 2.6 k/month) in the stand-alone case only; start Jan 2027; 100 % WI; no G&amp;A, no carry.</a:t>
+            </a:r>
+          </a:p>
+          <a:p>
+            <a:pPr>
+              <a:spcAft>
+                <a:spcPts val="600"/>
+              </a:spcAft>
+              <a:defRPr sz="1200"/>
+            </a:pPr>
+            <a:r>
+              <a:t>Realised price 0.81 x WTI from 37 PEMEX settlements (2020-22). Stand-alone NPV10 BTAX on GLJ: base -0.45 MM, high +0.33, low -1.57; flat-WTI break-even ~83.</a:t>
+            </a:r>
+          </a:p>
+          <a:p>
+            <a:pPr>
+              <a:spcAft>
+                <a:spcPts val="600"/>
+              </a:spcAft>
+              <a:defRPr sz="1200"/>
+            </a:pPr>
+            <a:r>
+              <a:t>Incremental to a producing TEC-10 (battery, disposal and area fees already carried): base +0.47 MM BTAX (+0.11 ATAX), payout 27 months, IRR 29 %; high +1.44; low -1.02; flat-WTI break-even ~66. At the 2023 model's 0.90 factor the base would be +0.99.</a:t>
+            </a:r>
+          </a:p>
+          <a:p>
+            <a:pPr>
+              <a:spcAft>
+                <a:spcPts val="600"/>
+              </a:spcAft>
+              <a:defRPr sz="1200"/>
+            </a:pPr>
+            <a:r>
+              <a:t>Royalties and area fees 41-44 % of revenue; fixed costs end the stand-alone base case at 54 months with 127 of 218 kbbl produced; incremental runs 175 months, 203 kbbl.</a:t>
+            </a:r>
+          </a:p>
+          <a:p>
+            <a:pPr>
+              <a:spcAft>
+                <a:spcPts val="600"/>
+              </a:spcAft>
+              <a:defRPr sz="1200"/>
+            </a:pPr>
+            <a:r>
+              <a:t>WTI ~USD 100 in mid-Sep 2026 on a supply disruption; long-term decks 70-80. The 2025 reform leaves contract terms unchanged (LSH transitorio Décimo, G-49).</a:t>
             </a:r>
           </a:p>
           <a:p>
@@ -3784,7 +3784,7 @@
               <a:defRPr sz="1400"/>
             </a:pPr>
             <a:r>
-              <a:t>Before sanction: (1) core-calibrated petrophysics of TEC-10's upper zone (G-47); (2) static gradient on TEC-10 after the multi-year shut-in; (3) re-index escalation when the Nov-2020 PPI is read (G-45; AFE currency USD confirmed); (4) pull the ten large-file binaries into data/raw (G-52; their text was read, docs/12).</a:t>
+              <a:t>Before sanction: (1) core-calibrated petrophysics of TEC-10's upper zone (G-47); (2) static gradient on TEC-10 after the multi-year shut-in; (3) escalation indexed on the drilling PPI (G-45 closed; AFE currency USD confirmed); (4) pull the ten large-file binaries into data/raw (G-52; their text was read, docs/12).</a:t>
             </a:r>
           </a:p>
           <a:p>
@@ -3966,7 +3966,7 @@
               <a:defRPr sz="1400"/>
             </a:pPr>
             <a:r>
-              <a:t>AFE is USD 1,572,724 (deleted formula explains the 5,000); escalated base USD 1.97 MM / CAD 2.74 MM.</a:t>
+              <a:t>AFE is USD 1,572,724 (deleted formula explains the 5,000); PPI-indexed to Sep 2026 (x1.297): USD 2.04 MM / CAD 2.84 MM.</a:t>
             </a:r>
           </a:p>
           <a:p>
@@ -3988,7 +3988,7 @@
               <a:defRPr sz="1400"/>
             </a:pPr>
             <a:r>
-              <a:t>Rebuilt economics at the measured 0.81 x WTI realised price: incremental to a producing TEC-10, NPV10 +0.27 MM at WTI 70, break-even ~65; stand-alone, break-even ~80.</a:t>
+              <a:t>Economics on GLJ's 1 Oct 2026 deck at 0.81 x WTI: incremental to a producing TEC-10, NPV10 +0.47 MM before tax (payout 27 months); stand-alone -0.45 MM; flat-WTI break-evens ~66 incremental, ~83 stand-alone.</a:t>
             </a:r>
           </a:p>
         </p:txBody>

</xml_diff>

<commit_message>
Review v4 addendum and handover/block decks: database-review economics and well-status updates
Co-Authored-By: Claude Opus 5.5 <noreply@anthropic.com>
Claude-Session: https://claude.ai/code/session_018uoQyz51GKm4nrnU51DLDG
</commit_message>
<xml_diff>
--- a/docs/Tecolutla_TEC12_Handover.pptx
+++ b/docs/Tecolutla_TEC12_Handover.pptx
@@ -3462,18 +3462,18 @@
               <a:defRPr sz="1200"/>
             </a:pPr>
             <a:r>
-              <a:t>GLJ 1 Oct 2026 prices (WTI 81 / 75 / 73, then +2 %/yr), costs +2 %/yr; 2023 royalty, tax and opex terms; PPI-indexed AFE; area fiscal charges (USD 2.6 k/month) in the stand-alone case only; start Jan 2027; 100 % WI; no G&amp;A, no carry.</a:t>
-            </a:r>
-          </a:p>
-          <a:p>
-            <a:pPr>
-              <a:spcAft>
-                <a:spcPts val="600"/>
-              </a:spcAft>
-              <a:defRPr sz="1200"/>
-            </a:pPr>
-            <a:r>
-              <a:t>Realised price 0.81 x WTI from 37 PEMEX settlements (2020-22). Stand-alone NPV10 BTAX on GLJ: base -0.45 MM, high +0.33, low -1.57; flat-WTI break-even ~83.</a:t>
+              <a:t>GLJ 1 Oct 2026 prices (WTI 81 / 75 / 73, then +2 %/yr), costs +2 %/yr; 2023 royalty, tax and opex terms; PPI-indexed AFE; area fiscal charges as paid 2024-25 (USD 5.2 k/month) in the stand-alone case only; start Jan 2027; 100 % WI; no G&amp;A, no carry.</a:t>
+            </a:r>
+          </a:p>
+          <a:p>
+            <a:pPr>
+              <a:spcAft>
+                <a:spcPts val="600"/>
+              </a:spcAft>
+              <a:defRPr sz="1200"/>
+            </a:pPr>
+            <a:r>
+              <a:t>Realised price 0.81 x WTI from 37 PEMEX settlements (2020-22). Stand-alone NPV10 BTAX on GLJ: base -0.57 MM, high +0.20, low -1.64; flat-WTI break-even ~86.</a:t>
             </a:r>
           </a:p>
           <a:p>
@@ -3988,7 +3988,7 @@
               <a:defRPr sz="1400"/>
             </a:pPr>
             <a:r>
-              <a:t>Economics on GLJ's 1 Oct 2026 deck at 0.81 x WTI: incremental to a producing TEC-10, NPV10 +0.47 MM before tax (payout 27 months); stand-alone -0.45 MM; flat-WTI break-evens ~66 incremental, ~83 stand-alone.</a:t>
+              <a:t>Economics on GLJ's 1 Oct 2026 deck at 0.81 x WTI: incremental to a producing TEC-10, NPV10 +0.47 MM before tax (payout 27 months); stand-alone -0.57 MM; flat-WTI break-evens ~66 incremental, ~86 stand-alone; GLJ's 2.08 MM rebuilt within 2 % (cost basis is the main difference).</a:t>
             </a:r>
           </a:p>
         </p:txBody>

</xml_diff>